<commit_message>
Fix Week 1 deck repair prompt (shared notesSlides)
The cloned slides copied their template's notesSlide relationship, so
several slides pointed at the same notes part (notesSlide3 was shared by
4 slides). A notes slide must belong to exactly one slide, so PowerPoint
flagged the file and offered to repair it on open.

Rebuild the deck copying only image and hyperlink relationships when
cloning a slide — never the notesSlide or slideLayout rels. The five new
slides now carry no speaker notes, each notes part maps 1:1 to its slide,
and the file opens without the repair prompt. Content and layout are
unchanged (15 slides, 37 images resolve, valid zip).

Co-Authored-By: Claude Opus 4.8 (1M context) <noreply@anthropic.com>
</commit_message>
<xml_diff>
--- a/assets/courses/ai-augmented-se/FPGAPA_AIAugmentedSE_Week01_The_AI_Augmented_Problem.pptx
+++ b/assets/courses/ai-augmented-se/FPGAPA_AIAugmentedSE_Week01_The_AI_Augmented_Problem.pptx
@@ -3114,7 +3114,7 @@
           <p:nvPr/>
         </p:nvPicPr>
         <p:blipFill>
-          <a:blip r:embed="rId4"/>
+          <a:blip r:embed="rId3"/>
           <a:stretch>
             <a:fillRect/>
           </a:stretch>
@@ -3604,7 +3604,7 @@
           <p:nvPr/>
         </p:nvPicPr>
         <p:blipFill>
-          <a:blip r:embed="rId4"/>
+          <a:blip r:embed="rId3"/>
           <a:stretch>
             <a:fillRect/>
           </a:stretch>
@@ -3932,7 +3932,7 @@
           <p:nvPr/>
         </p:nvPicPr>
         <p:blipFill>
-          <a:blip r:embed="rId4"/>
+          <a:blip r:embed="rId3"/>
           <a:stretch>
             <a:fillRect/>
           </a:stretch>
@@ -4826,7 +4826,7 @@
           <p:nvPr/>
         </p:nvPicPr>
         <p:blipFill>
-          <a:blip r:embed="rId8"/>
+          <a:blip r:embed="rId7"/>
           <a:stretch>
             <a:fillRect/>
           </a:stretch>
@@ -4850,7 +4850,7 @@
           <p:nvPr/>
         </p:nvPicPr>
         <p:blipFill>
-          <a:blip r:embed="rId9"/>
+          <a:blip r:embed="rId8"/>
           <a:stretch>
             <a:fillRect/>
           </a:stretch>
@@ -4874,7 +4874,7 @@
           <p:nvPr/>
         </p:nvPicPr>
         <p:blipFill>
-          <a:blip r:embed="rId10"/>
+          <a:blip r:embed="rId9"/>
           <a:stretch>
             <a:fillRect/>
           </a:stretch>
@@ -4898,7 +4898,7 @@
           <p:nvPr/>
         </p:nvPicPr>
         <p:blipFill>
-          <a:blip r:embed="rId11"/>
+          <a:blip r:embed="rId10"/>
           <a:stretch>
             <a:fillRect/>
           </a:stretch>

</xml_diff>

<commit_message>
Fix Week 1 deck repair prompt (shared notesSlides) (#13)
The cloned slides copied their template's notesSlide relationship, so
several slides pointed at the same notes part (notesSlide3 was shared by
4 slides). A notes slide must belong to exactly one slide, so PowerPoint
flagged the file and offered to repair it on open.

Rebuild the deck copying only image and hyperlink relationships when
cloning a slide — never the notesSlide or slideLayout rels. The five new
slides now carry no speaker notes, each notes part maps 1:1 to its slide,
and the file opens without the repair prompt. Content and layout are
unchanged (15 slides, 37 images resolve, valid zip).

Co-authored-by: Claude Opus 4.8 (1M context) <noreply@anthropic.com>
</commit_message>
<xml_diff>
--- a/assets/courses/ai-augmented-se/FPGAPA_AIAugmentedSE_Week01_The_AI_Augmented_Problem.pptx
+++ b/assets/courses/ai-augmented-se/FPGAPA_AIAugmentedSE_Week01_The_AI_Augmented_Problem.pptx
@@ -3114,7 +3114,7 @@
           <p:nvPr/>
         </p:nvPicPr>
         <p:blipFill>
-          <a:blip r:embed="rId4"/>
+          <a:blip r:embed="rId3"/>
           <a:stretch>
             <a:fillRect/>
           </a:stretch>
@@ -3604,7 +3604,7 @@
           <p:nvPr/>
         </p:nvPicPr>
         <p:blipFill>
-          <a:blip r:embed="rId4"/>
+          <a:blip r:embed="rId3"/>
           <a:stretch>
             <a:fillRect/>
           </a:stretch>
@@ -3932,7 +3932,7 @@
           <p:nvPr/>
         </p:nvPicPr>
         <p:blipFill>
-          <a:blip r:embed="rId4"/>
+          <a:blip r:embed="rId3"/>
           <a:stretch>
             <a:fillRect/>
           </a:stretch>
@@ -4826,7 +4826,7 @@
           <p:nvPr/>
         </p:nvPicPr>
         <p:blipFill>
-          <a:blip r:embed="rId8"/>
+          <a:blip r:embed="rId7"/>
           <a:stretch>
             <a:fillRect/>
           </a:stretch>
@@ -4850,7 +4850,7 @@
           <p:nvPr/>
         </p:nvPicPr>
         <p:blipFill>
-          <a:blip r:embed="rId9"/>
+          <a:blip r:embed="rId8"/>
           <a:stretch>
             <a:fillRect/>
           </a:stretch>
@@ -4874,7 +4874,7 @@
           <p:nvPr/>
         </p:nvPicPr>
         <p:blipFill>
-          <a:blip r:embed="rId10"/>
+          <a:blip r:embed="rId9"/>
           <a:stretch>
             <a:fillRect/>
           </a:stretch>
@@ -4898,7 +4898,7 @@
           <p:nvPr/>
         </p:nvPicPr>
         <p:blipFill>
-          <a:blip r:embed="rId11"/>
+          <a:blip r:embed="rId10"/>
           <a:stretch>
             <a:fillRect/>
           </a:stretch>

</xml_diff>